<commit_message>
Session 2 - Research/Designing.
In this session I dedicated myself to researching how to use GML code to create to of my most crucial mechanics, the camera system and the Enemy AI.

Designs for the buttons, main menu/start up screen have been completed as well.

Note To Self: These designs were made in Game maker and not with any other software.

This is also when I set-up the folders and sprites/Objects in Game maker ready for their designs.

I've also begun in doing the code for the camera system and have made substantial progress in it, this is the foundation of when coding has begun.
</commit_message>
<xml_diff>
--- a/Logs/Development Log and Alpha Testing.pptx
+++ b/Logs/Development Log and Alpha Testing.pptx
@@ -6,7 +6,9 @@
   </p:sldMasterIdLst>
   <p:sldIdLst>
     <p:sldId id="256" r:id="rId2"/>
-    <p:sldId id="257" r:id="rId3"/>
+    <p:sldId id="258" r:id="rId3"/>
+    <p:sldId id="259" r:id="rId4"/>
+    <p:sldId id="257" r:id="rId5"/>
   </p:sldIdLst>
   <p:sldSz cx="12192000" cy="6858000"/>
   <p:notesSz cx="6858000" cy="9144000"/>
@@ -451,7 +453,7 @@
           <a:p>
             <a:fld id="{846CE7D5-CF57-46EF-B807-FDD0502418D4}" type="datetimeFigureOut">
               <a:rPr lang="en-GB" smtClean="0"/>
-              <a:t>21/11/2025</a:t>
+              <a:t>24/11/2025</a:t>
             </a:fld>
             <a:endParaRPr lang="en-GB"/>
           </a:p>
@@ -621,7 +623,7 @@
           <a:p>
             <a:fld id="{846CE7D5-CF57-46EF-B807-FDD0502418D4}" type="datetimeFigureOut">
               <a:rPr lang="en-GB" smtClean="0"/>
-              <a:t>21/11/2025</a:t>
+              <a:t>24/11/2025</a:t>
             </a:fld>
             <a:endParaRPr lang="en-GB"/>
           </a:p>
@@ -801,7 +803,7 @@
           <a:p>
             <a:fld id="{846CE7D5-CF57-46EF-B807-FDD0502418D4}" type="datetimeFigureOut">
               <a:rPr lang="en-GB" smtClean="0"/>
-              <a:t>21/11/2025</a:t>
+              <a:t>24/11/2025</a:t>
             </a:fld>
             <a:endParaRPr lang="en-GB"/>
           </a:p>
@@ -971,7 +973,7 @@
           <a:p>
             <a:fld id="{846CE7D5-CF57-46EF-B807-FDD0502418D4}" type="datetimeFigureOut">
               <a:rPr lang="en-GB" smtClean="0"/>
-              <a:t>21/11/2025</a:t>
+              <a:t>24/11/2025</a:t>
             </a:fld>
             <a:endParaRPr lang="en-GB"/>
           </a:p>
@@ -1217,7 +1219,7 @@
           <a:p>
             <a:fld id="{846CE7D5-CF57-46EF-B807-FDD0502418D4}" type="datetimeFigureOut">
               <a:rPr lang="en-GB" smtClean="0"/>
-              <a:t>21/11/2025</a:t>
+              <a:t>24/11/2025</a:t>
             </a:fld>
             <a:endParaRPr lang="en-GB"/>
           </a:p>
@@ -1449,7 +1451,7 @@
           <a:p>
             <a:fld id="{846CE7D5-CF57-46EF-B807-FDD0502418D4}" type="datetimeFigureOut">
               <a:rPr lang="en-GB" smtClean="0"/>
-              <a:t>21/11/2025</a:t>
+              <a:t>24/11/2025</a:t>
             </a:fld>
             <a:endParaRPr lang="en-GB"/>
           </a:p>
@@ -1816,7 +1818,7 @@
           <a:p>
             <a:fld id="{846CE7D5-CF57-46EF-B807-FDD0502418D4}" type="datetimeFigureOut">
               <a:rPr lang="en-GB" smtClean="0"/>
-              <a:t>21/11/2025</a:t>
+              <a:t>24/11/2025</a:t>
             </a:fld>
             <a:endParaRPr lang="en-GB"/>
           </a:p>
@@ -1934,7 +1936,7 @@
           <a:p>
             <a:fld id="{846CE7D5-CF57-46EF-B807-FDD0502418D4}" type="datetimeFigureOut">
               <a:rPr lang="en-GB" smtClean="0"/>
-              <a:t>21/11/2025</a:t>
+              <a:t>24/11/2025</a:t>
             </a:fld>
             <a:endParaRPr lang="en-GB"/>
           </a:p>
@@ -2029,7 +2031,7 @@
           <a:p>
             <a:fld id="{846CE7D5-CF57-46EF-B807-FDD0502418D4}" type="datetimeFigureOut">
               <a:rPr lang="en-GB" smtClean="0"/>
-              <a:t>21/11/2025</a:t>
+              <a:t>24/11/2025</a:t>
             </a:fld>
             <a:endParaRPr lang="en-GB"/>
           </a:p>
@@ -2306,7 +2308,7 @@
           <a:p>
             <a:fld id="{846CE7D5-CF57-46EF-B807-FDD0502418D4}" type="datetimeFigureOut">
               <a:rPr lang="en-GB" smtClean="0"/>
-              <a:t>21/11/2025</a:t>
+              <a:t>24/11/2025</a:t>
             </a:fld>
             <a:endParaRPr lang="en-GB"/>
           </a:p>
@@ -2563,7 +2565,7 @@
           <a:p>
             <a:fld id="{846CE7D5-CF57-46EF-B807-FDD0502418D4}" type="datetimeFigureOut">
               <a:rPr lang="en-GB" smtClean="0"/>
-              <a:t>21/11/2025</a:t>
+              <a:t>24/11/2025</a:t>
             </a:fld>
             <a:endParaRPr lang="en-GB"/>
           </a:p>
@@ -2776,7 +2778,7 @@
           <a:p>
             <a:fld id="{846CE7D5-CF57-46EF-B807-FDD0502418D4}" type="datetimeFigureOut">
               <a:rPr lang="en-GB" smtClean="0"/>
-              <a:t>21/11/2025</a:t>
+              <a:t>24/11/2025</a:t>
             </a:fld>
             <a:endParaRPr lang="en-GB"/>
           </a:p>
@@ -3282,7 +3284,7 @@
         <p:spPr>
           <a:xfrm>
             <a:off x="5648215" y="563289"/>
-            <a:ext cx="3926490" cy="11141512"/>
+            <a:ext cx="3926490" cy="5970865"/>
           </a:xfrm>
           <a:prstGeom prst="rect">
             <a:avLst/>
@@ -3304,117 +3306,63 @@
           <a:lstStyle/>
           <a:p>
             <a:r>
+              <a:rPr lang="en-GB" sz="1400" dirty="0"/>
+              <a:t>Summary Of Session</a:t>
+            </a:r>
+          </a:p>
+          <a:p>
+            <a:endParaRPr lang="en-GB" sz="1600" dirty="0"/>
+          </a:p>
+          <a:p>
+            <a:r>
               <a:rPr lang="en-GB" sz="1600" dirty="0"/>
-              <a:t>Summary Of Session</a:t>
-            </a:r>
-          </a:p>
-          <a:p>
-            <a:endParaRPr lang="en-GB" dirty="0"/>
-          </a:p>
-          <a:p>
-            <a:r>
-              <a:rPr lang="en-GB" dirty="0"/>
               <a:t>I have finished outlining the design for the main office room.</a:t>
             </a:r>
           </a:p>
           <a:p>
-            <a:endParaRPr lang="en-GB" dirty="0"/>
-          </a:p>
-          <a:p>
-            <a:r>
-              <a:rPr lang="en-GB" dirty="0"/>
-              <a:t>I have corrected my enemies AMCD-01 to 03 to remove weird white spots left by the fill tool and now they are ready to be used in the game.</a:t>
-            </a:r>
-          </a:p>
-          <a:p>
-            <a:endParaRPr lang="en-GB" dirty="0"/>
-          </a:p>
-          <a:p>
-            <a:r>
-              <a:rPr lang="en-GB" dirty="0"/>
+            <a:endParaRPr lang="en-GB" sz="1600" dirty="0"/>
+          </a:p>
+          <a:p>
+            <a:r>
+              <a:rPr lang="en-GB" sz="1600" dirty="0"/>
+              <a:t>I have corrected my enemies AMCD-01 to 04 to remove weird white spots left by the fill tool and now they are ready to be used in the game.</a:t>
+            </a:r>
+          </a:p>
+          <a:p>
+            <a:endParaRPr lang="en-GB" sz="1600" dirty="0"/>
+          </a:p>
+          <a:p>
+            <a:r>
+              <a:rPr lang="en-GB" sz="1600" dirty="0"/>
               <a:t>I have created the design/animation stages for the doors.</a:t>
             </a:r>
           </a:p>
           <a:p>
-            <a:endParaRPr lang="en-GB" dirty="0"/>
-          </a:p>
-          <a:p>
-            <a:r>
-              <a:rPr lang="en-GB" dirty="0"/>
+            <a:endParaRPr lang="en-GB" sz="1600" dirty="0"/>
+          </a:p>
+          <a:p>
+            <a:r>
+              <a:rPr lang="en-GB" sz="1600" dirty="0"/>
               <a:t>I have designed the buttons.</a:t>
             </a:r>
           </a:p>
           <a:p>
-            <a:endParaRPr lang="en-GB" dirty="0"/>
-          </a:p>
-          <a:p>
-            <a:r>
-              <a:rPr lang="en-GB" dirty="0"/>
+            <a:endParaRPr lang="en-GB" sz="1600" dirty="0"/>
+          </a:p>
+          <a:p>
+            <a:r>
+              <a:rPr lang="en-GB" sz="1600" dirty="0"/>
               <a:t>Lastly, I have begun adding the designs into Gamemaker and going over them, refining them to look cleaner.</a:t>
             </a:r>
           </a:p>
           <a:p>
-            <a:endParaRPr lang="en-GB" dirty="0"/>
-          </a:p>
-          <a:p>
-            <a:endParaRPr lang="en-GB" dirty="0"/>
-          </a:p>
-          <a:p>
-            <a:endParaRPr lang="en-GB" dirty="0"/>
-          </a:p>
-          <a:p>
-            <a:endParaRPr lang="en-GB" dirty="0"/>
-          </a:p>
-          <a:p>
-            <a:endParaRPr lang="en-GB" dirty="0"/>
-          </a:p>
-          <a:p>
-            <a:endParaRPr lang="en-GB" dirty="0"/>
-          </a:p>
-          <a:p>
-            <a:endParaRPr lang="en-GB" dirty="0"/>
-          </a:p>
-          <a:p>
-            <a:endParaRPr lang="en-GB" dirty="0"/>
-          </a:p>
-          <a:p>
-            <a:endParaRPr lang="en-GB" dirty="0"/>
-          </a:p>
-          <a:p>
-            <a:endParaRPr lang="en-GB" dirty="0"/>
-          </a:p>
-          <a:p>
-            <a:endParaRPr lang="en-GB" dirty="0"/>
-          </a:p>
-          <a:p>
-            <a:endParaRPr lang="en-GB" dirty="0"/>
-          </a:p>
-          <a:p>
-            <a:endParaRPr lang="en-GB" dirty="0"/>
-          </a:p>
-          <a:p>
-            <a:endParaRPr lang="en-GB" dirty="0"/>
-          </a:p>
-          <a:p>
-            <a:endParaRPr lang="en-GB" dirty="0"/>
-          </a:p>
-          <a:p>
-            <a:endParaRPr lang="en-GB" dirty="0"/>
-          </a:p>
-          <a:p>
-            <a:endParaRPr lang="en-GB" dirty="0"/>
-          </a:p>
-          <a:p>
-            <a:endParaRPr lang="en-GB" dirty="0"/>
-          </a:p>
-          <a:p>
-            <a:endParaRPr lang="en-GB" dirty="0"/>
-          </a:p>
-          <a:p>
-            <a:endParaRPr lang="en-GB" dirty="0"/>
-          </a:p>
-          <a:p>
-            <a:endParaRPr lang="en-GB" dirty="0"/>
+            <a:endParaRPr lang="en-GB" sz="1600" dirty="0"/>
+          </a:p>
+          <a:p>
+            <a:r>
+              <a:rPr lang="en-GB" sz="1600" dirty="0"/>
+              <a:t>Note: I made the backgrounds black to show them in a much darker environment, I do have PNG images of them with transparent backgrounds as to make them easier to use In Game Maker.</a:t>
+            </a:r>
           </a:p>
         </p:txBody>
       </p:sp>
@@ -3433,7 +3381,7 @@
         <p:spPr>
           <a:xfrm>
             <a:off x="9651124" y="54413"/>
-            <a:ext cx="2438400" cy="9294852"/>
+            <a:ext cx="2438400" cy="5447645"/>
           </a:xfrm>
           <a:prstGeom prst="rect">
             <a:avLst/>
@@ -3455,102 +3403,73 @@
           <a:lstStyle/>
           <a:p>
             <a:r>
-              <a:rPr lang="en-GB" sz="1600" dirty="0"/>
+              <a:rPr lang="en-GB" sz="1200" dirty="0"/>
               <a:t>What to do for Next Session</a:t>
             </a:r>
           </a:p>
           <a:p>
+            <a:endParaRPr lang="en-GB" sz="1200" dirty="0"/>
+          </a:p>
+          <a:p>
+            <a:r>
+              <a:rPr lang="en-GB" sz="1200" dirty="0"/>
+              <a:t>Study more about the specific GML code needed for enemy AI/Camera system</a:t>
+            </a:r>
+          </a:p>
+          <a:p>
+            <a:endParaRPr lang="en-GB" sz="1200" dirty="0"/>
+          </a:p>
+          <a:p>
+            <a:r>
+              <a:rPr lang="en-GB" sz="1200" dirty="0"/>
+              <a:t>Enemy behaviour is unique between different enemies, as such they will have unique code.</a:t>
+            </a:r>
+          </a:p>
+          <a:p>
+            <a:endParaRPr lang="en-GB" sz="1200" dirty="0"/>
+          </a:p>
+          <a:p>
+            <a:r>
+              <a:rPr lang="en-GB" sz="1200" dirty="0"/>
+              <a:t>Map Out zone's layout inside the main room.</a:t>
+            </a:r>
+          </a:p>
+          <a:p>
+            <a:endParaRPr lang="en-GB" sz="1200" dirty="0"/>
+          </a:p>
+          <a:p>
+            <a:r>
+              <a:rPr lang="en-GB" sz="1200" dirty="0"/>
+              <a:t>Design Menu/Start-Up Screens.</a:t>
+            </a:r>
+          </a:p>
+          <a:p>
+            <a:endParaRPr lang="en-GB" sz="1200" dirty="0"/>
+          </a:p>
+          <a:p>
+            <a:r>
+              <a:rPr lang="en-GB" sz="1200" dirty="0"/>
+              <a:t>Create the rest of the sprites ready for when their designs are ready.</a:t>
+            </a:r>
+          </a:p>
+          <a:p>
+            <a:endParaRPr lang="en-GB" sz="1200" dirty="0"/>
+          </a:p>
+          <a:p>
+            <a:r>
+              <a:rPr lang="en-GB" sz="1200" dirty="0"/>
+              <a:t>Make the zones sprite canvas 1000x500 and give them a bold colour to start so you can begin mapping out the layout.</a:t>
+            </a:r>
+          </a:p>
+          <a:p>
+            <a:endParaRPr lang="en-GB" sz="1200" dirty="0"/>
+          </a:p>
+          <a:p>
+            <a:r>
+              <a:rPr lang="en-GB" sz="1200" dirty="0"/>
+              <a:t>Also, attempt to make the main room as large as possible as to have more flexibility when designing the levels/layouts/zones.</a:t>
+            </a:r>
             <a:endParaRPr lang="en-GB" sz="1600" dirty="0"/>
-          </a:p>
-          <a:p>
-            <a:r>
-              <a:rPr lang="en-GB" sz="1600" dirty="0"/>
-              <a:t>Design the 8 other zones in which are where the cameras will be and how the player can see the facility.</a:t>
-            </a:r>
-          </a:p>
-          <a:p>
-            <a:endParaRPr lang="en-GB" sz="1600" dirty="0"/>
-          </a:p>
-          <a:p>
-            <a:r>
-              <a:rPr lang="en-GB" sz="1600" dirty="0"/>
-              <a:t>Finish off Bulker</a:t>
-            </a:r>
-          </a:p>
-          <a:p>
-            <a:endParaRPr lang="en-GB" sz="1600" dirty="0"/>
-          </a:p>
-          <a:p>
-            <a:r>
-              <a:rPr lang="en-GB" sz="1600" dirty="0"/>
-              <a:t>Map Out zone's layout inside the main room.</a:t>
-            </a:r>
-          </a:p>
-          <a:p>
-            <a:endParaRPr lang="en-GB" sz="1600" dirty="0"/>
-          </a:p>
-          <a:p>
-            <a:r>
-              <a:rPr lang="en-GB" sz="1600" dirty="0"/>
-              <a:t>Design Menu/Start-Up Screens.</a:t>
-            </a:r>
-          </a:p>
-          <a:p>
-            <a:endParaRPr lang="en-GB" dirty="0"/>
-          </a:p>
-          <a:p>
-            <a:endParaRPr lang="en-GB" dirty="0"/>
-          </a:p>
-          <a:p>
-            <a:endParaRPr lang="en-GB" dirty="0"/>
-          </a:p>
-          <a:p>
-            <a:endParaRPr lang="en-GB" dirty="0"/>
-          </a:p>
-          <a:p>
-            <a:endParaRPr lang="en-GB" dirty="0"/>
-          </a:p>
-          <a:p>
-            <a:endParaRPr lang="en-GB" dirty="0"/>
-          </a:p>
-          <a:p>
-            <a:endParaRPr lang="en-GB" dirty="0"/>
-          </a:p>
-          <a:p>
-            <a:endParaRPr lang="en-GB" dirty="0"/>
-          </a:p>
-          <a:p>
-            <a:endParaRPr lang="en-GB" dirty="0"/>
-          </a:p>
-          <a:p>
-            <a:endParaRPr lang="en-GB" dirty="0"/>
-          </a:p>
-          <a:p>
-            <a:endParaRPr lang="en-GB" dirty="0"/>
-          </a:p>
-          <a:p>
-            <a:endParaRPr lang="en-GB" dirty="0"/>
-          </a:p>
-          <a:p>
-            <a:endParaRPr lang="en-GB" dirty="0"/>
-          </a:p>
-          <a:p>
-            <a:endParaRPr lang="en-GB" dirty="0"/>
-          </a:p>
-          <a:p>
-            <a:endParaRPr lang="en-GB" dirty="0"/>
-          </a:p>
-          <a:p>
-            <a:endParaRPr lang="en-GB" dirty="0"/>
-          </a:p>
-          <a:p>
-            <a:endParaRPr lang="en-GB" dirty="0"/>
-          </a:p>
-          <a:p>
-            <a:endParaRPr lang="en-GB" dirty="0"/>
-          </a:p>
-          <a:p>
-            <a:endParaRPr lang="en-GB" dirty="0"/>
           </a:p>
         </p:txBody>
       </p:sp>
@@ -3707,6 +3626,42 @@
           </a:prstGeom>
         </p:spPr>
       </p:pic>
+      <p:pic>
+        <p:nvPicPr>
+          <p:cNvPr id="7" name="Picture 6" descr="A blue rhinoceros with red eyes">
+            <a:extLst>
+              <a:ext uri="{FF2B5EF4-FFF2-40B4-BE49-F238E27FC236}">
+                <a16:creationId xmlns:a16="http://schemas.microsoft.com/office/drawing/2014/main" id="{0F8F764B-4E33-6B63-2454-0E3138EA0DFC}"/>
+              </a:ext>
+            </a:extLst>
+          </p:cNvPr>
+          <p:cNvPicPr>
+            <a:picLocks noChangeAspect="1"/>
+          </p:cNvPicPr>
+          <p:nvPr/>
+        </p:nvPicPr>
+        <p:blipFill>
+          <a:blip r:embed="rId8" cstate="print">
+            <a:extLst>
+              <a:ext uri="{28A0092B-C50C-407E-A947-70E740481C1C}">
+                <a14:useLocalDpi xmlns:a14="http://schemas.microsoft.com/office/drawing/2010/main" val="0"/>
+              </a:ext>
+            </a:extLst>
+          </a:blip>
+          <a:stretch>
+            <a:fillRect/>
+          </a:stretch>
+        </p:blipFill>
+        <p:spPr>
+          <a:xfrm>
+            <a:off x="1940996" y="4625615"/>
+            <a:ext cx="3348578" cy="2232385"/>
+          </a:xfrm>
+          <a:prstGeom prst="rect">
+            <a:avLst/>
+          </a:prstGeom>
+        </p:spPr>
+      </p:pic>
     </p:spTree>
     <p:extLst>
       <p:ext uri="{BB962C8B-B14F-4D97-AF65-F5344CB8AC3E}">
@@ -3726,6 +3681,745 @@
 </file>
 
 <file path=ppt/slides/slide2.xml><?xml version="1.0" encoding="utf-8"?>
+<p:sld xmlns:a="http://schemas.openxmlformats.org/drawingml/2006/main" xmlns:r="http://schemas.openxmlformats.org/officeDocument/2006/relationships" xmlns:p="http://schemas.openxmlformats.org/presentationml/2006/main">
+  <p:cSld>
+    <p:spTree>
+      <p:nvGrpSpPr>
+        <p:cNvPr id="1" name="">
+          <a:extLst>
+            <a:ext uri="{FF2B5EF4-FFF2-40B4-BE49-F238E27FC236}">
+              <a16:creationId xmlns:a16="http://schemas.microsoft.com/office/drawing/2014/main" id="{B2FB39EC-F8FE-ADA9-EA59-F1EC36434BDE}"/>
+            </a:ext>
+          </a:extLst>
+        </p:cNvPr>
+        <p:cNvGrpSpPr/>
+        <p:nvPr/>
+      </p:nvGrpSpPr>
+      <p:grpSpPr>
+        <a:xfrm>
+          <a:off x="0" y="0"/>
+          <a:ext cx="0" cy="0"/>
+          <a:chOff x="0" y="0"/>
+          <a:chExt cx="0" cy="0"/>
+        </a:xfrm>
+      </p:grpSpPr>
+      <p:sp>
+        <p:nvSpPr>
+          <p:cNvPr id="4" name="TextBox 3">
+            <a:extLst>
+              <a:ext uri="{FF2B5EF4-FFF2-40B4-BE49-F238E27FC236}">
+                <a16:creationId xmlns:a16="http://schemas.microsoft.com/office/drawing/2014/main" id="{576BDE55-6263-8575-7C13-EC317449D25F}"/>
+              </a:ext>
+            </a:extLst>
+          </p:cNvPr>
+          <p:cNvSpPr txBox="1"/>
+          <p:nvPr/>
+        </p:nvSpPr>
+        <p:spPr>
+          <a:xfrm>
+            <a:off x="7763992" y="90121"/>
+            <a:ext cx="1809641" cy="338554"/>
+          </a:xfrm>
+          <a:prstGeom prst="rect">
+            <a:avLst/>
+          </a:prstGeom>
+          <a:noFill/>
+          <a:ln>
+            <a:solidFill>
+              <a:schemeClr val="tx1"/>
+            </a:solidFill>
+          </a:ln>
+        </p:spPr>
+        <p:txBody>
+          <a:bodyPr rot="0" spcFirstLastPara="0" vertOverflow="overflow" horzOverflow="overflow" vert="horz" wrap="square" lIns="91440" tIns="45720" rIns="91440" bIns="45720" numCol="1" spcCol="0" rtlCol="0" fromWordArt="0" anchor="t" anchorCtr="0" forceAA="0" compatLnSpc="1">
+            <a:prstTxWarp prst="textNoShape">
+              <a:avLst/>
+            </a:prstTxWarp>
+            <a:spAutoFit/>
+          </a:bodyPr>
+          <a:lstStyle/>
+          <a:p>
+            <a:r>
+              <a:rPr lang="en-GB" sz="1600" dirty="0"/>
+              <a:t>Date – 24/11/2025</a:t>
+            </a:r>
+          </a:p>
+        </p:txBody>
+      </p:sp>
+      <p:sp>
+        <p:nvSpPr>
+          <p:cNvPr id="2" name="TextBox 1">
+            <a:extLst>
+              <a:ext uri="{FF2B5EF4-FFF2-40B4-BE49-F238E27FC236}">
+                <a16:creationId xmlns:a16="http://schemas.microsoft.com/office/drawing/2014/main" id="{6165D850-749B-B97D-752E-BEC348B613E1}"/>
+              </a:ext>
+            </a:extLst>
+          </p:cNvPr>
+          <p:cNvSpPr txBox="1"/>
+          <p:nvPr/>
+        </p:nvSpPr>
+        <p:spPr>
+          <a:xfrm>
+            <a:off x="5651845" y="90120"/>
+            <a:ext cx="1959856" cy="338554"/>
+          </a:xfrm>
+          <a:prstGeom prst="rect">
+            <a:avLst/>
+          </a:prstGeom>
+          <a:noFill/>
+          <a:ln>
+            <a:solidFill>
+              <a:schemeClr val="tx1"/>
+            </a:solidFill>
+          </a:ln>
+        </p:spPr>
+        <p:txBody>
+          <a:bodyPr rot="0" spcFirstLastPara="0" vertOverflow="overflow" horzOverflow="overflow" vert="horz" wrap="square" lIns="91440" tIns="45720" rIns="91440" bIns="45720" numCol="1" spcCol="0" rtlCol="0" fromWordArt="0" anchor="t" anchorCtr="0" forceAA="0" compatLnSpc="1">
+            <a:prstTxWarp prst="textNoShape">
+              <a:avLst/>
+            </a:prstTxWarp>
+            <a:spAutoFit/>
+          </a:bodyPr>
+          <a:lstStyle/>
+          <a:p>
+            <a:r>
+              <a:rPr lang="en-GB" sz="1600" dirty="0"/>
+              <a:t>Game Build V.0.1</a:t>
+            </a:r>
+          </a:p>
+        </p:txBody>
+      </p:sp>
+      <p:sp>
+        <p:nvSpPr>
+          <p:cNvPr id="3" name="TextBox 2">
+            <a:extLst>
+              <a:ext uri="{FF2B5EF4-FFF2-40B4-BE49-F238E27FC236}">
+                <a16:creationId xmlns:a16="http://schemas.microsoft.com/office/drawing/2014/main" id="{B05434DB-BE74-90C9-E4A8-6FC8304041B7}"/>
+              </a:ext>
+            </a:extLst>
+          </p:cNvPr>
+          <p:cNvSpPr txBox="1"/>
+          <p:nvPr/>
+        </p:nvSpPr>
+        <p:spPr>
+          <a:xfrm>
+            <a:off x="5648215" y="563289"/>
+            <a:ext cx="3926490" cy="4431983"/>
+          </a:xfrm>
+          <a:prstGeom prst="rect">
+            <a:avLst/>
+          </a:prstGeom>
+          <a:noFill/>
+          <a:ln>
+            <a:solidFill>
+              <a:schemeClr val="tx1"/>
+            </a:solidFill>
+          </a:ln>
+        </p:spPr>
+        <p:txBody>
+          <a:bodyPr rot="0" spcFirstLastPara="0" vertOverflow="overflow" horzOverflow="overflow" vert="horz" wrap="square" lIns="91440" tIns="45720" rIns="91440" bIns="45720" numCol="1" spcCol="0" rtlCol="0" fromWordArt="0" anchor="t" anchorCtr="0" forceAA="0" compatLnSpc="1">
+            <a:prstTxWarp prst="textNoShape">
+              <a:avLst/>
+            </a:prstTxWarp>
+            <a:spAutoFit/>
+          </a:bodyPr>
+          <a:lstStyle/>
+          <a:p>
+            <a:r>
+              <a:rPr lang="en-GB" sz="1400" dirty="0"/>
+              <a:t>Summary Of Session</a:t>
+            </a:r>
+          </a:p>
+          <a:p>
+            <a:endParaRPr lang="en-GB" sz="1400" dirty="0"/>
+          </a:p>
+          <a:p>
+            <a:r>
+              <a:rPr lang="en-GB" sz="1400" dirty="0"/>
+              <a:t>Colour coded each zone and named them correctly. These are to be used temporarily before the official designs are completed. The grey coloured zones are for the front views of both the vents and the doors.</a:t>
+            </a:r>
+          </a:p>
+          <a:p>
+            <a:endParaRPr lang="en-GB" sz="1400" dirty="0"/>
+          </a:p>
+          <a:p>
+            <a:r>
+              <a:rPr lang="en-GB" sz="1400" dirty="0"/>
+              <a:t>I have also Created a template for the Office.</a:t>
+            </a:r>
+          </a:p>
+          <a:p>
+            <a:r>
+              <a:rPr lang="en-GB" sz="1400" dirty="0"/>
+              <a:t>The Office will have a set size of 3000x1050, and the zones will have a set size of 2000x1050.</a:t>
+            </a:r>
+          </a:p>
+          <a:p>
+            <a:endParaRPr lang="en-GB" sz="1400" dirty="0"/>
+          </a:p>
+          <a:p>
+            <a:r>
+              <a:rPr lang="en-GB" sz="1400" dirty="0"/>
+              <a:t>The Buttons for both the vents and doors are made in Game Maker and will be 200x300px to have more flexibility in designing.</a:t>
+            </a:r>
+          </a:p>
+          <a:p>
+            <a:endParaRPr lang="en-GB" sz="1400" dirty="0"/>
+          </a:p>
+          <a:p>
+            <a:r>
+              <a:rPr lang="en-GB" sz="1400" dirty="0"/>
+              <a:t>The Camera button will start off being 300x100.</a:t>
+            </a:r>
+          </a:p>
+          <a:p>
+            <a:endParaRPr lang="en-GB" sz="1400" dirty="0"/>
+          </a:p>
+          <a:p>
+            <a:endParaRPr lang="en-GB" sz="1400" dirty="0"/>
+          </a:p>
+          <a:p>
+            <a:endParaRPr lang="en-GB" sz="1600" dirty="0"/>
+          </a:p>
+        </p:txBody>
+      </p:sp>
+      <p:sp>
+        <p:nvSpPr>
+          <p:cNvPr id="6" name="TextBox 5">
+            <a:extLst>
+              <a:ext uri="{FF2B5EF4-FFF2-40B4-BE49-F238E27FC236}">
+                <a16:creationId xmlns:a16="http://schemas.microsoft.com/office/drawing/2014/main" id="{5D546EC8-C3EF-D2D7-4576-CD84485BAD0C}"/>
+              </a:ext>
+            </a:extLst>
+          </p:cNvPr>
+          <p:cNvSpPr txBox="1"/>
+          <p:nvPr/>
+        </p:nvSpPr>
+        <p:spPr>
+          <a:xfrm>
+            <a:off x="9642445" y="54237"/>
+            <a:ext cx="2438400" cy="1754326"/>
+          </a:xfrm>
+          <a:prstGeom prst="rect">
+            <a:avLst/>
+          </a:prstGeom>
+          <a:noFill/>
+          <a:ln>
+            <a:solidFill>
+              <a:schemeClr val="tx1"/>
+            </a:solidFill>
+          </a:ln>
+        </p:spPr>
+        <p:txBody>
+          <a:bodyPr rot="0" spcFirstLastPara="0" vertOverflow="overflow" horzOverflow="overflow" vert="horz" wrap="square" lIns="91440" tIns="45720" rIns="91440" bIns="45720" numCol="1" spcCol="0" rtlCol="0" fromWordArt="0" anchor="t" anchorCtr="0" forceAA="0" compatLnSpc="1">
+            <a:prstTxWarp prst="textNoShape">
+              <a:avLst/>
+            </a:prstTxWarp>
+            <a:spAutoFit/>
+          </a:bodyPr>
+          <a:lstStyle/>
+          <a:p>
+            <a:r>
+              <a:rPr lang="en-GB" sz="1200" dirty="0"/>
+              <a:t>What to do for Next Session</a:t>
+            </a:r>
+          </a:p>
+          <a:p>
+            <a:endParaRPr lang="en-GB" sz="1200" dirty="0"/>
+          </a:p>
+          <a:p>
+            <a:r>
+              <a:rPr lang="en-GB" sz="1200" dirty="0"/>
+              <a:t>Allocate each zone to a location and name them specific to what contents are in it. For Example, 2 zones will be named obj_left_corridor and obj_left_corridor.</a:t>
+            </a:r>
+          </a:p>
+          <a:p>
+            <a:endParaRPr lang="en-GB" sz="1200" dirty="0"/>
+          </a:p>
+        </p:txBody>
+      </p:sp>
+      <p:pic>
+        <p:nvPicPr>
+          <p:cNvPr id="9" name="Picture 8">
+            <a:extLst>
+              <a:ext uri="{FF2B5EF4-FFF2-40B4-BE49-F238E27FC236}">
+                <a16:creationId xmlns:a16="http://schemas.microsoft.com/office/drawing/2014/main" id="{D5DA7A1B-0205-F5E4-D017-A101709C5534}"/>
+              </a:ext>
+            </a:extLst>
+          </p:cNvPr>
+          <p:cNvPicPr>
+            <a:picLocks noChangeAspect="1"/>
+          </p:cNvPicPr>
+          <p:nvPr/>
+        </p:nvPicPr>
+        <p:blipFill>
+          <a:blip r:embed="rId2"/>
+          <a:stretch>
+            <a:fillRect/>
+          </a:stretch>
+        </p:blipFill>
+        <p:spPr>
+          <a:xfrm>
+            <a:off x="35660" y="54237"/>
+            <a:ext cx="2581635" cy="2152950"/>
+          </a:xfrm>
+          <a:prstGeom prst="rect">
+            <a:avLst/>
+          </a:prstGeom>
+        </p:spPr>
+      </p:pic>
+      <p:pic>
+        <p:nvPicPr>
+          <p:cNvPr id="19" name="Picture 18">
+            <a:extLst>
+              <a:ext uri="{FF2B5EF4-FFF2-40B4-BE49-F238E27FC236}">
+                <a16:creationId xmlns:a16="http://schemas.microsoft.com/office/drawing/2014/main" id="{094D053A-FA5D-5E1A-4596-4B1AB3899244}"/>
+              </a:ext>
+            </a:extLst>
+          </p:cNvPr>
+          <p:cNvPicPr>
+            <a:picLocks noChangeAspect="1"/>
+          </p:cNvPicPr>
+          <p:nvPr/>
+        </p:nvPicPr>
+        <p:blipFill>
+          <a:blip r:embed="rId3"/>
+          <a:stretch>
+            <a:fillRect/>
+          </a:stretch>
+        </p:blipFill>
+        <p:spPr>
+          <a:xfrm>
+            <a:off x="3200014" y="90120"/>
+            <a:ext cx="2372056" cy="4239217"/>
+          </a:xfrm>
+          <a:prstGeom prst="rect">
+            <a:avLst/>
+          </a:prstGeom>
+        </p:spPr>
+      </p:pic>
+      <p:pic>
+        <p:nvPicPr>
+          <p:cNvPr id="23" name="Picture 22">
+            <a:extLst>
+              <a:ext uri="{FF2B5EF4-FFF2-40B4-BE49-F238E27FC236}">
+                <a16:creationId xmlns:a16="http://schemas.microsoft.com/office/drawing/2014/main" id="{BA939C8F-A31D-6446-512C-312CE13E262F}"/>
+              </a:ext>
+            </a:extLst>
+          </p:cNvPr>
+          <p:cNvPicPr>
+            <a:picLocks noChangeAspect="1"/>
+          </p:cNvPicPr>
+          <p:nvPr/>
+        </p:nvPicPr>
+        <p:blipFill>
+          <a:blip r:embed="rId4"/>
+          <a:srcRect r="3135"/>
+          <a:stretch>
+            <a:fillRect/>
+          </a:stretch>
+        </p:blipFill>
+        <p:spPr>
+          <a:xfrm>
+            <a:off x="149942" y="2348393"/>
+            <a:ext cx="2353069" cy="1495634"/>
+          </a:xfrm>
+          <a:prstGeom prst="rect">
+            <a:avLst/>
+          </a:prstGeom>
+        </p:spPr>
+      </p:pic>
+      <p:pic>
+        <p:nvPicPr>
+          <p:cNvPr id="25" name="Picture 24">
+            <a:extLst>
+              <a:ext uri="{FF2B5EF4-FFF2-40B4-BE49-F238E27FC236}">
+                <a16:creationId xmlns:a16="http://schemas.microsoft.com/office/drawing/2014/main" id="{366848E6-9BE0-02B5-CC0F-5C6426CD62E4}"/>
+              </a:ext>
+            </a:extLst>
+          </p:cNvPr>
+          <p:cNvPicPr>
+            <a:picLocks noChangeAspect="1"/>
+          </p:cNvPicPr>
+          <p:nvPr/>
+        </p:nvPicPr>
+        <p:blipFill>
+          <a:blip r:embed="rId5"/>
+          <a:stretch>
+            <a:fillRect/>
+          </a:stretch>
+        </p:blipFill>
+        <p:spPr>
+          <a:xfrm>
+            <a:off x="59421" y="4376015"/>
+            <a:ext cx="4326621" cy="2481985"/>
+          </a:xfrm>
+          <a:prstGeom prst="rect">
+            <a:avLst/>
+          </a:prstGeom>
+        </p:spPr>
+      </p:pic>
+    </p:spTree>
+    <p:extLst>
+      <p:ext uri="{BB962C8B-B14F-4D97-AF65-F5344CB8AC3E}">
+        <p14:creationId xmlns:p14="http://schemas.microsoft.com/office/powerpoint/2010/main" val="2368599957"/>
+      </p:ext>
+    </p:extLst>
+  </p:cSld>
+  <p:clrMapOvr>
+    <a:masterClrMapping/>
+  </p:clrMapOvr>
+</p:sld>
+</file>
+
+<file path=ppt/slides/slide3.xml><?xml version="1.0" encoding="utf-8"?>
+<p:sld xmlns:a="http://schemas.openxmlformats.org/drawingml/2006/main" xmlns:r="http://schemas.openxmlformats.org/officeDocument/2006/relationships" xmlns:p="http://schemas.openxmlformats.org/presentationml/2006/main">
+  <p:cSld>
+    <p:spTree>
+      <p:nvGrpSpPr>
+        <p:cNvPr id="1" name="">
+          <a:extLst>
+            <a:ext uri="{FF2B5EF4-FFF2-40B4-BE49-F238E27FC236}">
+              <a16:creationId xmlns:a16="http://schemas.microsoft.com/office/drawing/2014/main" id="{B71AF447-2503-6E06-EB64-6A29C299795D}"/>
+            </a:ext>
+          </a:extLst>
+        </p:cNvPr>
+        <p:cNvGrpSpPr/>
+        <p:nvPr/>
+      </p:nvGrpSpPr>
+      <p:grpSpPr>
+        <a:xfrm>
+          <a:off x="0" y="0"/>
+          <a:ext cx="0" cy="0"/>
+          <a:chOff x="0" y="0"/>
+          <a:chExt cx="0" cy="0"/>
+        </a:xfrm>
+      </p:grpSpPr>
+      <p:sp>
+        <p:nvSpPr>
+          <p:cNvPr id="4" name="TextBox 3">
+            <a:extLst>
+              <a:ext uri="{FF2B5EF4-FFF2-40B4-BE49-F238E27FC236}">
+                <a16:creationId xmlns:a16="http://schemas.microsoft.com/office/drawing/2014/main" id="{3ABD7D05-D183-64C6-1BA1-72453612143E}"/>
+              </a:ext>
+            </a:extLst>
+          </p:cNvPr>
+          <p:cNvSpPr txBox="1"/>
+          <p:nvPr/>
+        </p:nvSpPr>
+        <p:spPr>
+          <a:xfrm>
+            <a:off x="7763992" y="90121"/>
+            <a:ext cx="1809641" cy="338554"/>
+          </a:xfrm>
+          <a:prstGeom prst="rect">
+            <a:avLst/>
+          </a:prstGeom>
+          <a:noFill/>
+          <a:ln>
+            <a:solidFill>
+              <a:schemeClr val="tx1"/>
+            </a:solidFill>
+          </a:ln>
+        </p:spPr>
+        <p:txBody>
+          <a:bodyPr rot="0" spcFirstLastPara="0" vertOverflow="overflow" horzOverflow="overflow" vert="horz" wrap="square" lIns="91440" tIns="45720" rIns="91440" bIns="45720" numCol="1" spcCol="0" rtlCol="0" fromWordArt="0" anchor="t" anchorCtr="0" forceAA="0" compatLnSpc="1">
+            <a:prstTxWarp prst="textNoShape">
+              <a:avLst/>
+            </a:prstTxWarp>
+            <a:spAutoFit/>
+          </a:bodyPr>
+          <a:lstStyle/>
+          <a:p>
+            <a:r>
+              <a:rPr lang="en-GB" sz="1600" dirty="0"/>
+              <a:t>Date – 24/11/2025</a:t>
+            </a:r>
+          </a:p>
+        </p:txBody>
+      </p:sp>
+      <p:sp>
+        <p:nvSpPr>
+          <p:cNvPr id="2" name="TextBox 1">
+            <a:extLst>
+              <a:ext uri="{FF2B5EF4-FFF2-40B4-BE49-F238E27FC236}">
+                <a16:creationId xmlns:a16="http://schemas.microsoft.com/office/drawing/2014/main" id="{3E37F77A-82C0-2039-AD51-40366B52EBEB}"/>
+              </a:ext>
+            </a:extLst>
+          </p:cNvPr>
+          <p:cNvSpPr txBox="1"/>
+          <p:nvPr/>
+        </p:nvSpPr>
+        <p:spPr>
+          <a:xfrm>
+            <a:off x="5651845" y="90120"/>
+            <a:ext cx="1959856" cy="338554"/>
+          </a:xfrm>
+          <a:prstGeom prst="rect">
+            <a:avLst/>
+          </a:prstGeom>
+          <a:noFill/>
+          <a:ln>
+            <a:solidFill>
+              <a:schemeClr val="tx1"/>
+            </a:solidFill>
+          </a:ln>
+        </p:spPr>
+        <p:txBody>
+          <a:bodyPr rot="0" spcFirstLastPara="0" vertOverflow="overflow" horzOverflow="overflow" vert="horz" wrap="square" lIns="91440" tIns="45720" rIns="91440" bIns="45720" numCol="1" spcCol="0" rtlCol="0" fromWordArt="0" anchor="t" anchorCtr="0" forceAA="0" compatLnSpc="1">
+            <a:prstTxWarp prst="textNoShape">
+              <a:avLst/>
+            </a:prstTxWarp>
+            <a:spAutoFit/>
+          </a:bodyPr>
+          <a:lstStyle/>
+          <a:p>
+            <a:r>
+              <a:rPr lang="en-GB" sz="1600" dirty="0"/>
+              <a:t>Game Build V.0.1</a:t>
+            </a:r>
+          </a:p>
+        </p:txBody>
+      </p:sp>
+      <p:sp>
+        <p:nvSpPr>
+          <p:cNvPr id="3" name="TextBox 2">
+            <a:extLst>
+              <a:ext uri="{FF2B5EF4-FFF2-40B4-BE49-F238E27FC236}">
+                <a16:creationId xmlns:a16="http://schemas.microsoft.com/office/drawing/2014/main" id="{2886F3E7-61E5-445C-5038-15B1F86B5A87}"/>
+              </a:ext>
+            </a:extLst>
+          </p:cNvPr>
+          <p:cNvSpPr txBox="1"/>
+          <p:nvPr/>
+        </p:nvSpPr>
+        <p:spPr>
+          <a:xfrm>
+            <a:off x="5642854" y="578678"/>
+            <a:ext cx="3926490" cy="3354765"/>
+          </a:xfrm>
+          <a:prstGeom prst="rect">
+            <a:avLst/>
+          </a:prstGeom>
+          <a:noFill/>
+          <a:ln>
+            <a:solidFill>
+              <a:schemeClr val="tx1"/>
+            </a:solidFill>
+          </a:ln>
+        </p:spPr>
+        <p:txBody>
+          <a:bodyPr rot="0" spcFirstLastPara="0" vertOverflow="overflow" horzOverflow="overflow" vert="horz" wrap="square" lIns="91440" tIns="45720" rIns="91440" bIns="45720" numCol="1" spcCol="0" rtlCol="0" fromWordArt="0" anchor="t" anchorCtr="0" forceAA="0" compatLnSpc="1">
+            <a:prstTxWarp prst="textNoShape">
+              <a:avLst/>
+            </a:prstTxWarp>
+            <a:spAutoFit/>
+          </a:bodyPr>
+          <a:lstStyle/>
+          <a:p>
+            <a:r>
+              <a:rPr lang="en-GB" sz="1400" dirty="0"/>
+              <a:t>Summary Of Session</a:t>
+            </a:r>
+          </a:p>
+          <a:p>
+            <a:endParaRPr lang="en-GB" sz="1400" dirty="0"/>
+          </a:p>
+          <a:p>
+            <a:r>
+              <a:rPr lang="en-GB" sz="1400" dirty="0"/>
+              <a:t>I used View port feature on game maker to have the main camera be focused on the office.</a:t>
+            </a:r>
+          </a:p>
+          <a:p>
+            <a:endParaRPr lang="en-GB" sz="1400" dirty="0"/>
+          </a:p>
+          <a:p>
+            <a:r>
+              <a:rPr lang="en-GB" sz="1400" dirty="0"/>
+              <a:t>The code below is the camera, that when I put in camera_apply or shift view onto a button Object it will change OBJ_Camera’s position within the room. It is not done yet but is a massive leap in completing one of my most advanced mechanics.</a:t>
+            </a:r>
+          </a:p>
+          <a:p>
+            <a:endParaRPr lang="en-GB" sz="1400" dirty="0"/>
+          </a:p>
+          <a:p>
+            <a:endParaRPr lang="en-GB" sz="1400" dirty="0"/>
+          </a:p>
+          <a:p>
+            <a:endParaRPr lang="en-GB" sz="1400" dirty="0"/>
+          </a:p>
+          <a:p>
+            <a:endParaRPr lang="en-GB" sz="1600" dirty="0"/>
+          </a:p>
+        </p:txBody>
+      </p:sp>
+      <p:sp>
+        <p:nvSpPr>
+          <p:cNvPr id="6" name="TextBox 5">
+            <a:extLst>
+              <a:ext uri="{FF2B5EF4-FFF2-40B4-BE49-F238E27FC236}">
+                <a16:creationId xmlns:a16="http://schemas.microsoft.com/office/drawing/2014/main" id="{6C671371-B8F1-97C1-D2C5-BD2850E814D7}"/>
+              </a:ext>
+            </a:extLst>
+          </p:cNvPr>
+          <p:cNvSpPr txBox="1"/>
+          <p:nvPr/>
+        </p:nvSpPr>
+        <p:spPr>
+          <a:xfrm>
+            <a:off x="9642445" y="54237"/>
+            <a:ext cx="2438400" cy="646331"/>
+          </a:xfrm>
+          <a:prstGeom prst="rect">
+            <a:avLst/>
+          </a:prstGeom>
+          <a:noFill/>
+          <a:ln>
+            <a:solidFill>
+              <a:schemeClr val="tx1"/>
+            </a:solidFill>
+          </a:ln>
+        </p:spPr>
+        <p:txBody>
+          <a:bodyPr rot="0" spcFirstLastPara="0" vertOverflow="overflow" horzOverflow="overflow" vert="horz" wrap="square" lIns="91440" tIns="45720" rIns="91440" bIns="45720" numCol="1" spcCol="0" rtlCol="0" fromWordArt="0" anchor="t" anchorCtr="0" forceAA="0" compatLnSpc="1">
+            <a:prstTxWarp prst="textNoShape">
+              <a:avLst/>
+            </a:prstTxWarp>
+            <a:spAutoFit/>
+          </a:bodyPr>
+          <a:lstStyle/>
+          <a:p>
+            <a:r>
+              <a:rPr lang="en-GB" sz="1200" dirty="0"/>
+              <a:t>What to do for Next Session</a:t>
+            </a:r>
+          </a:p>
+          <a:p>
+            <a:endParaRPr lang="en-GB" sz="1200" dirty="0"/>
+          </a:p>
+          <a:p>
+            <a:endParaRPr lang="en-GB" sz="1200" dirty="0"/>
+          </a:p>
+        </p:txBody>
+      </p:sp>
+      <p:pic>
+        <p:nvPicPr>
+          <p:cNvPr id="27" name="Picture 26">
+            <a:extLst>
+              <a:ext uri="{FF2B5EF4-FFF2-40B4-BE49-F238E27FC236}">
+                <a16:creationId xmlns:a16="http://schemas.microsoft.com/office/drawing/2014/main" id="{F677CB03-D1DC-CB3F-CAE0-F8B146FE754F}"/>
+              </a:ext>
+            </a:extLst>
+          </p:cNvPr>
+          <p:cNvPicPr>
+            <a:picLocks noChangeAspect="1"/>
+          </p:cNvPicPr>
+          <p:nvPr/>
+        </p:nvPicPr>
+        <p:blipFill>
+          <a:blip r:embed="rId2"/>
+          <a:stretch>
+            <a:fillRect/>
+          </a:stretch>
+        </p:blipFill>
+        <p:spPr>
+          <a:xfrm>
+            <a:off x="231941" y="754545"/>
+            <a:ext cx="2512691" cy="5638018"/>
+          </a:xfrm>
+          <a:prstGeom prst="rect">
+            <a:avLst/>
+          </a:prstGeom>
+        </p:spPr>
+      </p:pic>
+      <p:sp>
+        <p:nvSpPr>
+          <p:cNvPr id="5" name="TextBox 4">
+            <a:extLst>
+              <a:ext uri="{FF2B5EF4-FFF2-40B4-BE49-F238E27FC236}">
+                <a16:creationId xmlns:a16="http://schemas.microsoft.com/office/drawing/2014/main" id="{3C6B70CF-F758-8FF9-4535-1E2605546C2E}"/>
+              </a:ext>
+            </a:extLst>
+          </p:cNvPr>
+          <p:cNvSpPr txBox="1"/>
+          <p:nvPr/>
+        </p:nvSpPr>
+        <p:spPr>
+          <a:xfrm>
+            <a:off x="0" y="54237"/>
+            <a:ext cx="1959856" cy="584775"/>
+          </a:xfrm>
+          <a:prstGeom prst="rect">
+            <a:avLst/>
+          </a:prstGeom>
+          <a:noFill/>
+          <a:ln>
+            <a:solidFill>
+              <a:schemeClr val="tx1"/>
+            </a:solidFill>
+          </a:ln>
+        </p:spPr>
+        <p:txBody>
+          <a:bodyPr rot="0" spcFirstLastPara="0" vertOverflow="overflow" horzOverflow="overflow" vert="horz" wrap="square" lIns="91440" tIns="45720" rIns="91440" bIns="45720" numCol="1" spcCol="0" rtlCol="0" fromWordArt="0" anchor="t" anchorCtr="0" forceAA="0" compatLnSpc="1">
+            <a:prstTxWarp prst="textNoShape">
+              <a:avLst/>
+            </a:prstTxWarp>
+            <a:spAutoFit/>
+          </a:bodyPr>
+          <a:lstStyle/>
+          <a:p>
+            <a:r>
+              <a:rPr lang="en-GB" sz="1600" dirty="0"/>
+              <a:t>Continuation of previous slide.</a:t>
+            </a:r>
+          </a:p>
+        </p:txBody>
+      </p:sp>
+      <p:pic>
+        <p:nvPicPr>
+          <p:cNvPr id="11" name="Picture 10">
+            <a:extLst>
+              <a:ext uri="{FF2B5EF4-FFF2-40B4-BE49-F238E27FC236}">
+                <a16:creationId xmlns:a16="http://schemas.microsoft.com/office/drawing/2014/main" id="{10266355-A36C-5972-ED51-B27E7586F80B}"/>
+              </a:ext>
+            </a:extLst>
+          </p:cNvPr>
+          <p:cNvPicPr>
+            <a:picLocks noChangeAspect="1"/>
+          </p:cNvPicPr>
+          <p:nvPr/>
+        </p:nvPicPr>
+        <p:blipFill>
+          <a:blip r:embed="rId3"/>
+          <a:stretch>
+            <a:fillRect/>
+          </a:stretch>
+        </p:blipFill>
+        <p:spPr>
+          <a:xfrm>
+            <a:off x="3038494" y="3756230"/>
+            <a:ext cx="8921565" cy="2581366"/>
+          </a:xfrm>
+          <a:prstGeom prst="rect">
+            <a:avLst/>
+          </a:prstGeom>
+        </p:spPr>
+      </p:pic>
+    </p:spTree>
+    <p:extLst>
+      <p:ext uri="{BB962C8B-B14F-4D97-AF65-F5344CB8AC3E}">
+        <p14:creationId xmlns:p14="http://schemas.microsoft.com/office/powerpoint/2010/main" val="3460468714"/>
+      </p:ext>
+    </p:extLst>
+  </p:cSld>
+  <p:clrMapOvr>
+    <a:masterClrMapping/>
+  </p:clrMapOvr>
+</p:sld>
+</file>
+
+<file path=ppt/slides/slide4.xml><?xml version="1.0" encoding="utf-8"?>
 <p:sld xmlns:a="http://schemas.openxmlformats.org/drawingml/2006/main" xmlns:r="http://schemas.openxmlformats.org/officeDocument/2006/relationships" xmlns:p="http://schemas.openxmlformats.org/presentationml/2006/main">
   <p:cSld>
     <p:spTree>

</xml_diff>